<commit_message>
docs: add TCO cost analysis slide to presentation and update architecture blueprint
</commit_message>
<xml_diff>
--- a/references/azureops_gitops_architecture.pptx
+++ b/references/azureops_gitops_architecture.pptx
@@ -9,6 +9,7 @@
     <p:sldId id="257" r:id="rId8"/>
     <p:sldId id="258" r:id="rId9"/>
     <p:sldId id="259" r:id="rId10"/>
+    <p:sldId id="260" r:id="rId11"/>
   </p:sldIdLst>
   <p:sldSz cx="12191695" cy="6858000" type="screen4x3"/>
   <p:notesSz cx="6858000" cy="9144000"/>
@@ -4853,6 +4854,462 @@
 </p:sld>
 </file>
 
+<file path=ppt/slides/slide5.xml><?xml version="1.0" encoding="utf-8"?>
+<p:sld xmlns:a="http://schemas.openxmlformats.org/drawingml/2006/main" xmlns:p="http://schemas.openxmlformats.org/presentationml/2006/main" xmlns:r="http://schemas.openxmlformats.org/officeDocument/2006/relationships">
+  <p:cSld>
+    <p:spTree>
+      <p:nvGrpSpPr>
+        <p:cNvPr id="1" name=""/>
+        <p:cNvGrpSpPr/>
+        <p:nvPr/>
+      </p:nvGrpSpPr>
+      <p:grpSpPr/>
+      <p:sp>
+        <p:nvSpPr>
+          <p:cNvPr id="2" name="Rectangle 1"/>
+          <p:cNvSpPr/>
+          <p:nvPr/>
+        </p:nvSpPr>
+        <p:spPr>
+          <a:xfrm>
+            <a:off x="0" y="0"/>
+            <a:ext cx="12191695" cy="6858000"/>
+          </a:xfrm>
+          <a:prstGeom prst="rect">
+            <a:avLst/>
+          </a:prstGeom>
+          <a:solidFill>
+            <a:srgbClr val="F8FAFC"/>
+          </a:solidFill>
+          <a:ln>
+            <a:noFill/>
+          </a:ln>
+        </p:spPr>
+        <p:style>
+          <a:lnRef idx="1">
+            <a:schemeClr val="accent1"/>
+          </a:lnRef>
+          <a:fillRef idx="3">
+            <a:schemeClr val="accent1"/>
+          </a:fillRef>
+          <a:effectRef idx="2">
+            <a:schemeClr val="accent1"/>
+          </a:effectRef>
+          <a:fontRef idx="minor">
+            <a:schemeClr val="lt1"/>
+          </a:fontRef>
+        </p:style>
+        <p:txBody>
+          <a:bodyPr rtlCol="0" anchor="ctr"/>
+          <a:lstStyle/>
+          <a:p>
+            <a:pPr algn="ctr"/>
+          </a:p>
+        </p:txBody>
+      </p:sp>
+      <p:sp>
+        <p:nvSpPr>
+          <p:cNvPr id="3" name="TextBox 2"/>
+          <p:cNvSpPr txBox="1"/>
+          <p:nvPr/>
+        </p:nvSpPr>
+        <p:spPr>
+          <a:xfrm>
+            <a:off x="914400" y="457200"/>
+            <a:ext cx="10362895" cy="914400"/>
+          </a:xfrm>
+          <a:prstGeom prst="rect">
+            <a:avLst/>
+          </a:prstGeom>
+          <a:noFill/>
+        </p:spPr>
+        <p:txBody>
+          <a:bodyPr wrap="none">
+            <a:spAutoFit/>
+          </a:bodyPr>
+          <a:lstStyle/>
+          <a:p>
+            <a:pPr>
+              <a:defRPr sz="2800" b="1">
+                <a:solidFill>
+                  <a:srgbClr val="0F172A"/>
+                </a:solidFill>
+                <a:latin typeface="Segoe UI"/>
+              </a:defRPr>
+            </a:pPr>
+            <a:r>
+              <a:t>Cost Analysis &amp; Total Cost of Ownership</a:t>
+            </a:r>
+          </a:p>
+        </p:txBody>
+      </p:sp>
+      <p:sp>
+        <p:nvSpPr>
+          <p:cNvPr id="4" name="TextBox 3"/>
+          <p:cNvSpPr txBox="1"/>
+          <p:nvPr/>
+        </p:nvSpPr>
+        <p:spPr>
+          <a:xfrm>
+            <a:off x="914400" y="1463040"/>
+            <a:ext cx="4754880" cy="4572000"/>
+          </a:xfrm>
+          <a:prstGeom prst="rect">
+            <a:avLst/>
+          </a:prstGeom>
+          <a:noFill/>
+        </p:spPr>
+        <p:txBody>
+          <a:bodyPr wrap="square">
+            <a:spAutoFit/>
+          </a:bodyPr>
+          <a:lstStyle/>
+          <a:p>
+            <a:pPr>
+              <a:spcAft>
+                <a:spcPts val="1500"/>
+              </a:spcAft>
+              <a:defRPr sz="1600" b="1">
+                <a:solidFill>
+                  <a:srgbClr val="0EA5E9"/>
+                </a:solidFill>
+              </a:defRPr>
+            </a:pPr>
+            <a:r>
+              <a:t>ONE-TIME SETUP COSTS</a:t>
+            </a:r>
+          </a:p>
+          <a:p>
+            <a:pPr>
+              <a:spcAft>
+                <a:spcPts val="800"/>
+              </a:spcAft>
+              <a:defRPr sz="1300">
+                <a:solidFill>
+                  <a:srgbClr val="0F172A"/>
+                </a:solidFill>
+              </a:defRPr>
+            </a:pPr>
+            <a:r>
+              <a:t>• Azure Logical Resource Groups: </a:t>
+            </a:r>
+            <a:r>
+              <a:rPr b="1">
+                <a:solidFill>
+                  <a:srgbClr val="22C55E"/>
+                </a:solidFill>
+              </a:rPr>
+              <a:t>$0.00</a:t>
+            </a:r>
+          </a:p>
+          <a:p>
+            <a:pPr>
+              <a:spcAft>
+                <a:spcPts val="800"/>
+              </a:spcAft>
+              <a:defRPr sz="1300">
+                <a:solidFill>
+                  <a:srgbClr val="0F172A"/>
+                </a:solidFill>
+              </a:defRPr>
+            </a:pPr>
+            <a:r>
+              <a:t>• GitHub / Azure DevOps Repositories: </a:t>
+            </a:r>
+            <a:r>
+              <a:rPr b="1">
+                <a:solidFill>
+                  <a:srgbClr val="22C55E"/>
+                </a:solidFill>
+              </a:rPr>
+              <a:t>$0.00</a:t>
+            </a:r>
+          </a:p>
+          <a:p>
+            <a:pPr>
+              <a:spcAft>
+                <a:spcPts val="800"/>
+              </a:spcAft>
+              <a:defRPr sz="1300">
+                <a:solidFill>
+                  <a:srgbClr val="0F172A"/>
+                </a:solidFill>
+              </a:defRPr>
+            </a:pPr>
+            <a:r>
+              <a:t>• Telemetry Routing (Monitor/Defender): </a:t>
+            </a:r>
+            <a:r>
+              <a:rPr b="1">
+                <a:solidFill>
+                  <a:srgbClr val="22C55E"/>
+                </a:solidFill>
+              </a:rPr>
+              <a:t>$0.00</a:t>
+            </a:r>
+          </a:p>
+          <a:p>
+            <a:pPr>
+              <a:spcAft>
+                <a:spcPts val="800"/>
+              </a:spcAft>
+              <a:defRPr sz="1300">
+                <a:solidFill>
+                  <a:srgbClr val="0F172A"/>
+                </a:solidFill>
+              </a:defRPr>
+            </a:pPr>
+            <a:r>
+              <a:t>• Initial Python App Setup &amp; Deploy: </a:t>
+            </a:r>
+            <a:r>
+              <a:rPr b="1">
+                <a:solidFill>
+                  <a:srgbClr val="22C55E"/>
+                </a:solidFill>
+              </a:rPr>
+              <a:t>$0.00</a:t>
+            </a:r>
+          </a:p>
+          <a:p>
+            <a:pPr>
+              <a:spcAft>
+                <a:spcPts val="800"/>
+              </a:spcAft>
+              <a:defRPr sz="1300">
+                <a:solidFill>
+                  <a:srgbClr val="0F172A"/>
+                </a:solidFill>
+              </a:defRPr>
+            </a:pPr>
+            <a:r>
+              <a:t>• TOTAL ONE-TIME EXPENSES: </a:t>
+            </a:r>
+            <a:r>
+              <a:rPr b="1">
+                <a:solidFill>
+                  <a:srgbClr val="22C55E"/>
+                </a:solidFill>
+              </a:rPr>
+              <a:t>$0.00 (Zero-Cost Setup)</a:t>
+            </a:r>
+          </a:p>
+        </p:txBody>
+      </p:sp>
+      <p:sp>
+        <p:nvSpPr>
+          <p:cNvPr id="5" name="TextBox 4"/>
+          <p:cNvSpPr txBox="1"/>
+          <p:nvPr/>
+        </p:nvSpPr>
+        <p:spPr>
+          <a:xfrm>
+            <a:off x="6217920" y="1463040"/>
+            <a:ext cx="5029200" cy="4572000"/>
+          </a:xfrm>
+          <a:prstGeom prst="rect">
+            <a:avLst/>
+          </a:prstGeom>
+          <a:noFill/>
+        </p:spPr>
+        <p:txBody>
+          <a:bodyPr wrap="square">
+            <a:spAutoFit/>
+          </a:bodyPr>
+          <a:lstStyle/>
+          <a:p>
+            <a:pPr>
+              <a:spcAft>
+                <a:spcPts val="1500"/>
+              </a:spcAft>
+              <a:defRPr sz="1600" b="1">
+                <a:solidFill>
+                  <a:srgbClr val="0EA5E9"/>
+                </a:solidFill>
+              </a:defRPr>
+            </a:pPr>
+            <a:r>
+              <a:t>MONTHLY RECURRING COSTS (1k Events)</a:t>
+            </a:r>
+          </a:p>
+          <a:p>
+            <a:pPr>
+              <a:spcAft>
+                <a:spcPts val="800"/>
+              </a:spcAft>
+              <a:defRPr sz="1200">
+                <a:solidFill>
+                  <a:srgbClr val="0F172A"/>
+                </a:solidFill>
+              </a:defRPr>
+            </a:pPr>
+            <a:r>
+              <a:t>• Azure Event Grid (Telemetry Router): </a:t>
+            </a:r>
+            <a:r>
+              <a:rPr b="1">
+                <a:solidFill>
+                  <a:srgbClr val="0EA5E9"/>
+                </a:solidFill>
+              </a:rPr>
+              <a:t>$0.00 (Under 100k events/mo free)</a:t>
+            </a:r>
+          </a:p>
+          <a:p>
+            <a:pPr>
+              <a:spcAft>
+                <a:spcPts val="800"/>
+              </a:spcAft>
+              <a:defRPr sz="1200">
+                <a:solidFill>
+                  <a:srgbClr val="0F172A"/>
+                </a:solidFill>
+              </a:defRPr>
+            </a:pPr>
+            <a:r>
+              <a:t>• Azure Functions (Serverless Compute): </a:t>
+            </a:r>
+            <a:r>
+              <a:rPr b="1">
+                <a:solidFill>
+                  <a:srgbClr val="0F172A"/>
+                </a:solidFill>
+              </a:rPr>
+              <a:t>~$0.80 (Pay-as-you-go executions)</a:t>
+            </a:r>
+          </a:p>
+          <a:p>
+            <a:pPr>
+              <a:spcAft>
+                <a:spcPts val="800"/>
+              </a:spcAft>
+              <a:defRPr sz="1200">
+                <a:solidFill>
+                  <a:srgbClr val="0F172A"/>
+                </a:solidFill>
+              </a:defRPr>
+            </a:pPr>
+            <a:r>
+              <a:t>• Azure Storage (Logs &amp; Meta): </a:t>
+            </a:r>
+            <a:r>
+              <a:rPr b="1">
+                <a:solidFill>
+                  <a:srgbClr val="0F172A"/>
+                </a:solidFill>
+              </a:rPr>
+              <a:t>~$0.50 (Hot LRS standard storage)</a:t>
+            </a:r>
+          </a:p>
+          <a:p>
+            <a:pPr>
+              <a:spcAft>
+                <a:spcPts val="800"/>
+              </a:spcAft>
+              <a:defRPr sz="1200">
+                <a:solidFill>
+                  <a:srgbClr val="0F172A"/>
+                </a:solidFill>
+              </a:defRPr>
+            </a:pPr>
+            <a:r>
+              <a:t>• Azure OpenAI Service (GPT-4o API): </a:t>
+            </a:r>
+            <a:r>
+              <a:rPr b="1">
+                <a:solidFill>
+                  <a:srgbClr val="0F172A"/>
+                </a:solidFill>
+              </a:rPr>
+              <a:t>~$39.00 (Estimated token utilization)</a:t>
+            </a:r>
+          </a:p>
+          <a:p>
+            <a:pPr>
+              <a:spcAft>
+                <a:spcPts val="800"/>
+              </a:spcAft>
+              <a:defRPr sz="1200">
+                <a:solidFill>
+                  <a:srgbClr val="0F172A"/>
+                </a:solidFill>
+              </a:defRPr>
+            </a:pPr>
+            <a:r>
+              <a:t>• TOTAL ESTIMATED MONTHLY OVERHEAD: </a:t>
+            </a:r>
+            <a:r>
+              <a:rPr b="1">
+                <a:solidFill>
+                  <a:srgbClr val="0EA5E9"/>
+                </a:solidFill>
+              </a:rPr>
+              <a:t>~$40.30 / Month</a:t>
+            </a:r>
+          </a:p>
+        </p:txBody>
+      </p:sp>
+      <p:sp>
+        <p:nvSpPr>
+          <p:cNvPr id="6" name="Rectangle 5"/>
+          <p:cNvSpPr/>
+          <p:nvPr/>
+        </p:nvSpPr>
+        <p:spPr>
+          <a:xfrm>
+            <a:off x="914400" y="5303520"/>
+            <a:ext cx="10362895" cy="914400"/>
+          </a:xfrm>
+          <a:prstGeom prst="rect">
+            <a:avLst/>
+          </a:prstGeom>
+          <a:solidFill>
+            <a:srgbClr val="0F172A"/>
+          </a:solidFill>
+          <a:ln>
+            <a:noFill/>
+          </a:ln>
+        </p:spPr>
+        <p:style>
+          <a:lnRef idx="1">
+            <a:schemeClr val="accent1"/>
+          </a:lnRef>
+          <a:fillRef idx="3">
+            <a:schemeClr val="accent1"/>
+          </a:fillRef>
+          <a:effectRef idx="2">
+            <a:schemeClr val="accent1"/>
+          </a:effectRef>
+          <a:fontRef idx="minor">
+            <a:schemeClr val="lt1"/>
+          </a:fontRef>
+        </p:style>
+        <p:txBody>
+          <a:bodyPr rtlCol="0" anchor="ctr"/>
+          <a:lstStyle/>
+          <a:p>
+            <a:pPr algn="ctr">
+              <a:defRPr sz="1250" b="1">
+                <a:solidFill>
+                  <a:srgbClr val="FFFFFF"/>
+                </a:solidFill>
+                <a:latin typeface="Segoe UI"/>
+              </a:defRPr>
+            </a:pPr>
+            <a:r>
+              <a:t>TCO COMPARISON: Auto-remediation costs ~$0.04 per incident vs. ~$150 - $300 in engineering labor per manual remediation ticket. (A 99.98% operational cost reduction).</a:t>
+            </a:r>
+          </a:p>
+        </p:txBody>
+      </p:sp>
+    </p:spTree>
+  </p:cSld>
+  <p:clrMapOvr>
+    <a:masterClrMapping/>
+  </p:clrMapOvr>
+</p:sld>
+</file>
+
 <file path=ppt/theme/theme1.xml><?xml version="1.0" encoding="utf-8"?>
 <a:theme xmlns:a="http://schemas.openxmlformats.org/drawingml/2006/main" name="Office Theme">
   <a:themeElements>

</xml_diff>